<commit_message>
Simplify slide language for general audience
</commit_message>
<xml_diff>
--- a/presentation/Research_Update_2026-11-01.pptx
+++ b/presentation/Research_Update_2026-11-01.pptx
@@ -9841,7 +9841,7 @@
                 </a:solidFill>
                 <a:latin typeface="Arial"/>
               </a:rPr>
-              <a:t>20 final submissions in the nominally</a:t>
+              <a:t>20 final submissions in tasks labeled</a:t>
             </a:r>
           </a:p>
           <a:p>
@@ -9860,7 +9860,7 @@
                 </a:solidFill>
                 <a:latin typeface="Arial"/>
               </a:rPr>
-              <a:t>unavailable condition</a:t>
+              <a:t>"unavailable" by the benchmark</a:t>
             </a:r>
           </a:p>
         </p:txBody>
@@ -10810,7 +10810,7 @@
                 </a:solidFill>
                 <a:latin typeface="Arial"/>
               </a:rPr>
-              <a:t>The extra flag was false in the nominally unavailable condition.</a:t>
+              <a:t>The extra flag was false for tasks labeled "unavailable".</a:t>
             </a:r>
           </a:p>
         </p:txBody>
@@ -11479,7 +11479,7 @@
                 </a:solidFill>
                 <a:latin typeface="Arial"/>
               </a:rPr>
-              <a:t>Authored 20 finite task families;</a:t>
+              <a:t>Built 20 types of security tasks;</a:t>
             </a:r>
           </a:p>
           <a:p>
@@ -11670,7 +11670,7 @@
                 </a:solidFill>
                 <a:latin typeface="Arial"/>
               </a:rPr>
-              <a:t>Rechecked 1,820 authored</a:t>
+              <a:t>Rechecked 1,820 outcomes on</a:t>
             </a:r>
           </a:p>
           <a:p>
@@ -11689,7 +11689,7 @@
                 </a:solidFill>
                 <a:latin typeface="Arial"/>
               </a:rPr>
-              <a:t>candidate/condition decisions.</a:t>
+              <a:t>examples we designed.</a:t>
             </a:r>
           </a:p>
         </p:txBody>
@@ -11861,7 +11861,7 @@
                 </a:solidFill>
                 <a:latin typeface="Arial"/>
               </a:rPr>
-              <a:t>Completed 30 separate, excluded</a:t>
+              <a:t>Completed 30 separate trial runs</a:t>
             </a:r>
           </a:p>
           <a:p>
@@ -11880,7 +11880,7 @@
                 </a:solidFill>
                 <a:latin typeface="Arial"/>
               </a:rPr>
-              <a:t>feasibility episodes.</a:t>
+              <a:t>with a revised checker.</a:t>
             </a:r>
           </a:p>
         </p:txBody>
@@ -12569,7 +12569,7 @@
                 </a:solidFill>
                 <a:latin typeface="Arial"/>
               </a:rPr>
-              <a:t>Old intermediate logs: 0 of 81 action receipts stored raw test results.</a:t>
+              <a:t>Old logs: none of 81 intermediate checks saved the raw test result.</a:t>
             </a:r>
           </a:p>
         </p:txBody>

</xml_diff>